<commit_message>
Final: Complete Bluestock MF Capstone
</commit_message>
<xml_diff>
--- a/reports/Bluestock_MF_Presentation.pptx
+++ b/reports/Bluestock_MF_Presentation.pptx
@@ -158,7 +158,7 @@
 <file path=ppt/revisionInfo.xml><?xml version="1.0" encoding="utf-8"?>
 <p1510:revInfo xmlns:a="http://schemas.openxmlformats.org/drawingml/2006/main" xmlns:r="http://schemas.openxmlformats.org/officeDocument/2006/relationships" xmlns:p1510="http://schemas.microsoft.com/office/powerpoint/2015/10/main">
   <p1510:revLst>
-    <p1510:client id="{41B656FD-B977-43A8-A0E7-4589E975485B}" v="4" dt="2026-06-13T22:02:22.179"/>
+    <p1510:client id="{41B656FD-B977-43A8-A0E7-4589E975485B}" v="6" dt="2026-06-13T23:01:34.822"/>
   </p1510:revLst>
 </p1510:revInfo>
 </file>
@@ -168,7 +168,7 @@
   <pc:docChgLst>
     <pc:chgData name="Hansdah Babu" userId="1811ab9e0b21157e" providerId="LiveId" clId="{B3999061-0A46-4186-992E-8313CA5F16F6}"/>
     <pc:docChg chg="undo custSel modSld">
-      <pc:chgData name="Hansdah Babu" userId="1811ab9e0b21157e" providerId="LiveId" clId="{B3999061-0A46-4186-992E-8313CA5F16F6}" dt="2026-06-13T22:02:55.694" v="7" actId="14100"/>
+      <pc:chgData name="Hansdah Babu" userId="1811ab9e0b21157e" providerId="LiveId" clId="{B3999061-0A46-4186-992E-8313CA5F16F6}" dt="2026-06-13T23:01:37.475" v="14" actId="20577"/>
       <pc:docMkLst>
         <pc:docMk/>
       </pc:docMkLst>
@@ -187,6 +187,21 @@
           </ac:grpSpMkLst>
         </pc:grpChg>
       </pc:sldChg>
+      <pc:sldChg chg="modSp mod modNotes">
+        <pc:chgData name="Hansdah Babu" userId="1811ab9e0b21157e" providerId="LiveId" clId="{B3999061-0A46-4186-992E-8313CA5F16F6}" dt="2026-06-13T23:01:37.475" v="14" actId="20577"/>
+        <pc:sldMkLst>
+          <pc:docMk/>
+          <pc:sldMk cId="0" sldId="257"/>
+        </pc:sldMkLst>
+        <pc:spChg chg="mod">
+          <ac:chgData name="Hansdah Babu" userId="1811ab9e0b21157e" providerId="LiveId" clId="{B3999061-0A46-4186-992E-8313CA5F16F6}" dt="2026-06-13T23:01:37.475" v="14" actId="20577"/>
+          <ac:spMkLst>
+            <pc:docMk/>
+            <pc:sldMk cId="0" sldId="257"/>
+            <ac:spMk id="37" creationId="{00000000-0000-0000-0000-000000000000}"/>
+          </ac:spMkLst>
+        </pc:spChg>
+      </pc:sldChg>
       <pc:sldChg chg="modSp mod">
         <pc:chgData name="Hansdah Babu" userId="1811ab9e0b21157e" providerId="LiveId" clId="{B3999061-0A46-4186-992E-8313CA5F16F6}" dt="2026-06-13T22:02:55.694" v="7" actId="14100"/>
         <pc:sldMkLst>
@@ -199,6 +214,37 @@
             <pc:docMk/>
             <pc:sldMk cId="0" sldId="259"/>
             <ac:spMk id="20" creationId="{00000000-0000-0000-0000-000000000000}"/>
+          </ac:spMkLst>
+        </pc:spChg>
+      </pc:sldChg>
+      <pc:sldChg chg="modSp mod">
+        <pc:chgData name="Hansdah Babu" userId="1811ab9e0b21157e" providerId="LiveId" clId="{B3999061-0A46-4186-992E-8313CA5F16F6}" dt="2026-06-13T22:47:51.647" v="10" actId="14100"/>
+        <pc:sldMkLst>
+          <pc:docMk/>
+          <pc:sldMk cId="0" sldId="261"/>
+        </pc:sldMkLst>
+        <pc:spChg chg="mod">
+          <ac:chgData name="Hansdah Babu" userId="1811ab9e0b21157e" providerId="LiveId" clId="{B3999061-0A46-4186-992E-8313CA5F16F6}" dt="2026-06-13T22:47:02.137" v="8" actId="1036"/>
+          <ac:spMkLst>
+            <pc:docMk/>
+            <pc:sldMk cId="0" sldId="261"/>
+            <ac:spMk id="25" creationId="{00000000-0000-0000-0000-000000000000}"/>
+          </ac:spMkLst>
+        </pc:spChg>
+        <pc:spChg chg="mod">
+          <ac:chgData name="Hansdah Babu" userId="1811ab9e0b21157e" providerId="LiveId" clId="{B3999061-0A46-4186-992E-8313CA5F16F6}" dt="2026-06-13T22:47:47.803" v="9" actId="14100"/>
+          <ac:spMkLst>
+            <pc:docMk/>
+            <pc:sldMk cId="0" sldId="261"/>
+            <ac:spMk id="29" creationId="{00000000-0000-0000-0000-000000000000}"/>
+          </ac:spMkLst>
+        </pc:spChg>
+        <pc:spChg chg="mod">
+          <ac:chgData name="Hansdah Babu" userId="1811ab9e0b21157e" providerId="LiveId" clId="{B3999061-0A46-4186-992E-8313CA5F16F6}" dt="2026-06-13T22:47:51.647" v="10" actId="14100"/>
+          <ac:spMkLst>
+            <pc:docMk/>
+            <pc:sldMk cId="0" sldId="261"/>
+            <ac:spMk id="30" creationId="{00000000-0000-0000-0000-000000000000}"/>
           </ac:spMkLst>
         </pc:spChg>
       </pc:sldChg>
@@ -1538,8 +1584,8 @@
         </p:nvSpPr>
         <p:spPr>
           <a:xfrm>
-            <a:off x="2857500" y="512763"/>
-            <a:ext cx="3429000" cy="2566987"/>
+            <a:off x="2290763" y="512763"/>
+            <a:ext cx="4562475" cy="2566987"/>
           </a:xfrm>
           <a:prstGeom prst="rect">
             <a:avLst/>
@@ -2410,8 +2456,8 @@
         </p:nvSpPr>
         <p:spPr>
           <a:xfrm>
-            <a:off x="2857500" y="512763"/>
-            <a:ext cx="3429000" cy="2566987"/>
+            <a:off x="2290763" y="512763"/>
+            <a:ext cx="4562475" cy="2566987"/>
           </a:xfrm>
           <a:prstGeom prst="rect">
             <a:avLst/>
@@ -13791,13 +13837,13 @@
             <a:bodyPr lIns="0" tIns="0" rIns="0" bIns="0" rtlCol="0" anchor="ctr"/>
             <a:lstStyle/>
             <a:p>
-              <a:pPr algn="l">
+              <a:pPr>
                 <a:lnSpc>
                   <a:spcPts val="2070"/>
                 </a:lnSpc>
               </a:pPr>
               <a:r>
-                <a:rPr lang="en-US" sz="1725">
+                <a:rPr lang="en-US" sz="1725" dirty="0">
                   <a:solidFill>
                     <a:srgbClr val="0D1B2A"/>
                   </a:solidFill>
@@ -13806,7 +13852,39 @@
                   <a:cs typeface="DM Sans"/>
                   <a:sym typeface="DM Sans"/>
                 </a:rPr>
-                <a:t>40 Mutual Fund Schemes  | 10 Major Fund Houses | Jan 2022 – Dec 2025  |  73,080 Historical NAV Records  |  31,238 investor transactions  | Multiple Benchmark Indices | Portfolio Holdings and Sector Allocations | SIP and AUM Industry Statistics</a:t>
+                <a:t>40 Mutual Fund Schemes  | 10 Major Fund Houses | Jan 2022 – Dec 2025  |  </a:t>
+              </a:r>
+              <a:r>
+                <a:rPr lang="en-IN" dirty="0"/>
+                <a:t>19,798</a:t>
+              </a:r>
+              <a:r>
+                <a:rPr lang="en-US" sz="1725" dirty="0">
+                  <a:solidFill>
+                    <a:srgbClr val="0D1B2A"/>
+                  </a:solidFill>
+                  <a:latin typeface="DM Sans"/>
+                  <a:ea typeface="DM Sans"/>
+                  <a:cs typeface="DM Sans"/>
+                  <a:sym typeface="DM Sans"/>
+                </a:rPr>
+                <a:t> Historical NAV Records  |  </a:t>
+              </a:r>
+              <a:r>
+                <a:rPr lang="en-IN" dirty="0"/>
+                <a:t>32,778</a:t>
+              </a:r>
+              <a:r>
+                <a:rPr lang="en-US" sz="1725" dirty="0">
+                  <a:solidFill>
+                    <a:srgbClr val="0D1B2A"/>
+                  </a:solidFill>
+                  <a:latin typeface="DM Sans"/>
+                  <a:ea typeface="DM Sans"/>
+                  <a:cs typeface="DM Sans"/>
+                  <a:sym typeface="DM Sans"/>
+                </a:rPr>
+                <a:t> investor transactions  | Multiple Benchmark Indices | Portfolio Holdings and Sector Allocations | SIP and AUM Industry Statistics</a:t>
               </a:r>
             </a:p>
             <a:p>
@@ -13815,7 +13893,7 @@
                   <a:spcPts val="2070"/>
                 </a:lnSpc>
               </a:pPr>
-              <a:endParaRPr lang="en-US" sz="1725">
+              <a:endParaRPr lang="en-US" sz="1725" dirty="0">
                 <a:solidFill>
                   <a:srgbClr val="0D1B2A"/>
                 </a:solidFill>
@@ -13832,7 +13910,7 @@
                 </a:lnSpc>
               </a:pPr>
               <a:r>
-                <a:rPr lang="en-US" sz="1725">
+                <a:rPr lang="en-US" sz="1725" dirty="0">
                   <a:solidFill>
                     <a:srgbClr val="0D1B2A"/>
                   </a:solidFill>
@@ -16371,7 +16449,7 @@
                 </a:lnSpc>
               </a:pPr>
               <a:r>
-                <a:rPr lang="en-US" sz="1425">
+                <a:rPr lang="en-US" sz="1425" dirty="0">
                   <a:solidFill>
                     <a:srgbClr val="0D1B2A"/>
                   </a:solidFill>
@@ -17015,7 +17093,7 @@
                 </a:lnSpc>
               </a:pPr>
               <a:r>
-                <a:rPr lang="en-US" sz="1425">
+                <a:rPr lang="en-US" sz="1425" dirty="0" err="1">
                   <a:solidFill>
                     <a:srgbClr val="0D1B2A"/>
                   </a:solidFill>
@@ -17024,7 +17102,43 @@
                   <a:cs typeface="DM Sans"/>
                   <a:sym typeface="DM Sans"/>
                 </a:rPr>
-                <a:t>amfi_code, date, nav, daily_return_pct </a:t>
+                <a:t>amfi_code</a:t>
+              </a:r>
+              <a:r>
+                <a:rPr lang="en-US" sz="1425" dirty="0">
+                  <a:solidFill>
+                    <a:srgbClr val="0D1B2A"/>
+                  </a:solidFill>
+                  <a:latin typeface="DM Sans"/>
+                  <a:ea typeface="DM Sans"/>
+                  <a:cs typeface="DM Sans"/>
+                  <a:sym typeface="DM Sans"/>
+                </a:rPr>
+                <a:t>, date, nav, </a:t>
+              </a:r>
+              <a:r>
+                <a:rPr lang="en-US" sz="1425" dirty="0" err="1">
+                  <a:solidFill>
+                    <a:srgbClr val="0D1B2A"/>
+                  </a:solidFill>
+                  <a:latin typeface="DM Sans"/>
+                  <a:ea typeface="DM Sans"/>
+                  <a:cs typeface="DM Sans"/>
+                  <a:sym typeface="DM Sans"/>
+                </a:rPr>
+                <a:t>daily_return_pct</a:t>
+              </a:r>
+              <a:r>
+                <a:rPr lang="en-US" sz="1425" dirty="0">
+                  <a:solidFill>
+                    <a:srgbClr val="0D1B2A"/>
+                  </a:solidFill>
+                  <a:latin typeface="DM Sans"/>
+                  <a:ea typeface="DM Sans"/>
+                  <a:cs typeface="DM Sans"/>
+                  <a:sym typeface="DM Sans"/>
+                </a:rPr>
+                <a:t> </a:t>
               </a:r>
             </a:p>
           </p:txBody>
@@ -21869,7 +21983,7 @@
               </a:spcBef>
             </a:pPr>
             <a:r>
-              <a:rPr lang="en-US" sz="1425">
+              <a:rPr lang="en-US" sz="1425" dirty="0">
                 <a:solidFill>
                   <a:srgbClr val="000000"/>
                 </a:solidFill>
@@ -25257,7 +25371,7 @@
         </p:nvSpPr>
         <p:spPr>
           <a:xfrm>
-            <a:off x="6543249" y="1573149"/>
+            <a:off x="6543249" y="1632234"/>
             <a:ext cx="4279354" cy="3968466"/>
           </a:xfrm>
           <a:custGeom>
@@ -25439,15 +25553,15 @@
         </p:nvSpPr>
         <p:spPr>
           <a:xfrm>
-            <a:off x="2947128" y="9544020"/>
-            <a:ext cx="2919264" cy="209550"/>
+            <a:off x="2947127" y="9544020"/>
+            <a:ext cx="3511243" cy="218008"/>
           </a:xfrm>
           <a:prstGeom prst="rect">
             <a:avLst/>
           </a:prstGeom>
         </p:spPr>
         <p:txBody>
-          <a:bodyPr lIns="0" tIns="0" rIns="0" bIns="0" rtlCol="0" anchor="t">
+          <a:bodyPr wrap="square" lIns="0" tIns="0" rIns="0" bIns="0" rtlCol="0" anchor="t">
             <a:spAutoFit/>
           </a:bodyPr>
           <a:lstStyle/>
@@ -25461,7 +25575,7 @@
               </a:spcBef>
             </a:pPr>
             <a:r>
-              <a:rPr lang="en-US" sz="1425" i="1">
+              <a:rPr lang="en-US" sz="1425" i="1" dirty="0">
                 <a:solidFill>
                   <a:srgbClr val="4A5568"/>
                 </a:solidFill>
@@ -25483,15 +25597,15 @@
         </p:nvSpPr>
         <p:spPr>
           <a:xfrm>
-            <a:off x="11458572" y="9591645"/>
-            <a:ext cx="4106168" cy="209550"/>
+            <a:off x="11458571" y="9591645"/>
+            <a:ext cx="4467227" cy="218008"/>
           </a:xfrm>
           <a:prstGeom prst="rect">
             <a:avLst/>
           </a:prstGeom>
         </p:spPr>
         <p:txBody>
-          <a:bodyPr lIns="0" tIns="0" rIns="0" bIns="0" rtlCol="0" anchor="t">
+          <a:bodyPr wrap="square" lIns="0" tIns="0" rIns="0" bIns="0" rtlCol="0" anchor="t">
             <a:spAutoFit/>
           </a:bodyPr>
           <a:lstStyle/>
@@ -25505,7 +25619,7 @@
               </a:spcBef>
             </a:pPr>
             <a:r>
-              <a:rPr lang="en-US" sz="1425" i="1">
+              <a:rPr lang="en-US" sz="1425" i="1" dirty="0">
                 <a:solidFill>
                   <a:srgbClr val="4A5568"/>
                 </a:solidFill>
@@ -39231,7 +39345,7 @@
                 </a:lnSpc>
               </a:pPr>
               <a:r>
-                <a:rPr lang="en-US" sz="1425">
+                <a:rPr lang="en-US" sz="1425" dirty="0">
                   <a:solidFill>
                     <a:srgbClr val="4A5568"/>
                   </a:solidFill>
@@ -40620,7 +40734,7 @@
               </a:spcBef>
             </a:pPr>
             <a:r>
-              <a:rPr lang="en-US" sz="1425" i="1">
+              <a:rPr lang="en-US" sz="1425" i="1" dirty="0">
                 <a:solidFill>
                   <a:srgbClr val="4A5568"/>
                 </a:solidFill>

</xml_diff>